<commit_message>
0.2.4: tpl describe --plain for human console use
Prints the raw Markdown description without the JSON envelope (the
envelope escapes newlines as \n, unreadable on a terminal). Agents
keep the envelope contract; --plain is the documented escape hatch.

Co-Authored-By: Claude Fable 5 <noreply@anthropic.com>
</commit_message>
<xml_diff>
--- a/plugin/skills/powerpoint/assets/neutral-template.pptx
+++ b/plugin/skills/powerpoint/assets/neutral-template.pptx
@@ -4,10 +4,13 @@
   <p:sldMasterIdLst>
     <p:sldMasterId id="2147483648" r:id="rId1"/>
   </p:sldMasterIdLst>
+  <p:notesMasterIdLst>
+    <p:notesMasterId r:id="rId3"/>
+  </p:notesMasterIdLst>
   <p:sldIdLst>
-    <p:sldId id="256" r:id="rId7"/>
+    <p:sldId id="256" r:id="rId2"/>
   </p:sldIdLst>
-  <p:sldSz cx="12191695" cy="6858000" type="screen4x3"/>
+  <p:sldSz cx="12192000" cy="6858000"/>
   <p:notesSz cx="6858000" cy="9144000"/>
   <p:defaultTextStyle>
     <a:defPPr>
@@ -104,11 +107,27 @@
       </a:defRPr>
     </a:lvl9pPr>
   </p:defaultTextStyle>
+  <p:extLst>
+    <p:ext uri="{EFAFB233-063F-42B5-8137-9DF3F51BA10A}">
+      <p15:sldGuideLst xmlns:p15="http://schemas.microsoft.com/office/powerpoint/2012/main">
+        <p15:guide id="1" orient="horz" pos="2160">
+          <p15:clr>
+            <a:srgbClr val="A4A3A4"/>
+          </p15:clr>
+        </p15:guide>
+        <p15:guide id="2" pos="2880">
+          <p15:clr>
+            <a:srgbClr val="A4A3A4"/>
+          </p15:clr>
+        </p15:guide>
+      </p15:sldGuideLst>
+    </p:ext>
+  </p:extLst>
 </p:presentation>
 </file>
 
 <file path=ppt/notesMasters/notesMaster1.xml><?xml version="1.0" encoding="utf-8"?>
-<p:notesMaster xmlns:a="http://schemas.openxmlformats.org/drawingml/2006/main" xmlns:p="http://schemas.openxmlformats.org/presentationml/2006/main" xmlns:r="http://schemas.openxmlformats.org/officeDocument/2006/relationships">
+<p:notesMaster xmlns:a="http://schemas.openxmlformats.org/drawingml/2006/main" xmlns:r="http://schemas.openxmlformats.org/officeDocument/2006/relationships" xmlns:p="http://schemas.openxmlformats.org/presentationml/2006/main">
   <p:cSld>
     <p:bg>
       <p:bgRef idx="1001">
@@ -129,241 +148,16 @@
           <a:chExt cx="0" cy="0"/>
         </a:xfrm>
       </p:grpSpPr>
-      <p:sp>
-        <p:nvSpPr>
-          <p:cNvPr id="2" name="Header Placeholder 1"/>
-          <p:cNvSpPr>
-            <a:spLocks noGrp="1"/>
-          </p:cNvSpPr>
-          <p:nvPr>
-            <p:ph type="hdr" sz="quarter"/>
-          </p:nvPr>
-        </p:nvSpPr>
-        <p:spPr>
-          <a:xfrm>
-            <a:off x="0" y="0"/>
-            <a:ext cx="2971800" cy="457200"/>
-          </a:xfrm>
-          <a:prstGeom prst="rect">
-            <a:avLst/>
-          </a:prstGeom>
-        </p:spPr>
-        <p:txBody>
-          <a:bodyPr vert="horz" lIns="91440" tIns="45720" rIns="91440" bIns="45720" rtlCol="0"/>
-          <a:lstStyle>
-            <a:lvl1pPr algn="l">
-              <a:defRPr sz="1200"/>
-            </a:lvl1pPr>
-          </a:lstStyle>
-          <a:p>
-            <a:endParaRPr lang="en-US"/>
-          </a:p>
-        </p:txBody>
-      </p:sp>
-      <p:sp>
-        <p:nvSpPr>
-          <p:cNvPr id="3" name="Date Placeholder 2"/>
-          <p:cNvSpPr>
-            <a:spLocks noGrp="1"/>
-          </p:cNvSpPr>
-          <p:nvPr>
-            <p:ph type="dt" idx="1"/>
-          </p:nvPr>
-        </p:nvSpPr>
-        <p:spPr>
-          <a:xfrm>
-            <a:off x="3884613" y="0"/>
-            <a:ext cx="2971800" cy="457200"/>
-          </a:xfrm>
-          <a:prstGeom prst="rect">
-            <a:avLst/>
-          </a:prstGeom>
-        </p:spPr>
-        <p:txBody>
-          <a:bodyPr vert="horz" lIns="91440" tIns="45720" rIns="91440" bIns="45720" rtlCol="0"/>
-          <a:lstStyle>
-            <a:lvl1pPr algn="r">
-              <a:defRPr sz="1200"/>
-            </a:lvl1pPr>
-          </a:lstStyle>
-          <a:p>
-            <a:fld id="{0F89C1C7-3DCD-1040-A9CF-14679D8B5DDD}" type="datetimeFigureOut">
-              <a:rPr lang="en-US" smtClean="0"/>
-              <a:t>10/17/16</a:t>
-            </a:fld>
-            <a:endParaRPr lang="en-US"/>
-          </a:p>
-        </p:txBody>
-      </p:sp>
-      <p:sp>
-        <p:nvSpPr>
-          <p:cNvPr id="4" name="Slide Image Placeholder 3"/>
-          <p:cNvSpPr>
-            <a:spLocks noGrp="1" noRot="1" noChangeAspect="1"/>
-          </p:cNvSpPr>
-          <p:nvPr>
-            <p:ph type="sldImg" idx="2"/>
-          </p:nvPr>
-        </p:nvSpPr>
-        <p:spPr>
-          <a:xfrm>
-            <a:off x="1143000" y="685800"/>
-            <a:ext cx="4572000" cy="3429000"/>
-          </a:xfrm>
-          <a:prstGeom prst="rect">
-            <a:avLst/>
-          </a:prstGeom>
-          <a:noFill/>
-          <a:ln w="12700">
-            <a:solidFill>
-              <a:prstClr val="black"/>
-            </a:solidFill>
-          </a:ln>
-        </p:spPr>
-        <p:txBody>
-          <a:bodyPr vert="horz" lIns="91440" tIns="45720" rIns="91440" bIns="45720" rtlCol="0" anchor="ctr"/>
-          <a:lstStyle/>
-          <a:p>
-            <a:endParaRPr lang="en-US"/>
-          </a:p>
-        </p:txBody>
-      </p:sp>
-      <p:sp>
-        <p:nvSpPr>
-          <p:cNvPr id="5" name="Notes Placeholder 4"/>
-          <p:cNvSpPr>
-            <a:spLocks noGrp="1"/>
-          </p:cNvSpPr>
-          <p:nvPr>
-            <p:ph type="body" sz="quarter" idx="3"/>
-          </p:nvPr>
-        </p:nvSpPr>
-        <p:spPr>
-          <a:xfrm>
-            <a:off x="685800" y="4343400"/>
-            <a:ext cx="5486400" cy="4114800"/>
-          </a:xfrm>
-          <a:prstGeom prst="rect">
-            <a:avLst/>
-          </a:prstGeom>
-        </p:spPr>
-        <p:txBody>
-          <a:bodyPr vert="horz" lIns="91440" tIns="45720" rIns="91440" bIns="45720" rtlCol="0"/>
-          <a:lstStyle/>
-          <a:p>
-            <a:pPr lvl="0"/>
-            <a:r>
-              <a:rPr lang="en-US" smtClean="0"/>
-              <a:t>Click to edit Master text styles</a:t>
-            </a:r>
-          </a:p>
-          <a:p>
-            <a:pPr lvl="1"/>
-            <a:r>
-              <a:rPr lang="en-US" smtClean="0"/>
-              <a:t>Second level</a:t>
-            </a:r>
-          </a:p>
-          <a:p>
-            <a:pPr lvl="2"/>
-            <a:r>
-              <a:rPr lang="en-US" smtClean="0"/>
-              <a:t>Third level</a:t>
-            </a:r>
-          </a:p>
-          <a:p>
-            <a:pPr lvl="3"/>
-            <a:r>
-              <a:rPr lang="en-US" smtClean="0"/>
-              <a:t>Fourth level</a:t>
-            </a:r>
-          </a:p>
-          <a:p>
-            <a:pPr lvl="4"/>
-            <a:r>
-              <a:rPr lang="en-US" smtClean="0"/>
-              <a:t>Fifth level</a:t>
-            </a:r>
-            <a:endParaRPr lang="en-US"/>
-          </a:p>
-        </p:txBody>
-      </p:sp>
-      <p:sp>
-        <p:nvSpPr>
-          <p:cNvPr id="6" name="Footer Placeholder 5"/>
-          <p:cNvSpPr>
-            <a:spLocks noGrp="1"/>
-          </p:cNvSpPr>
-          <p:nvPr>
-            <p:ph type="ftr" sz="quarter" idx="4"/>
-          </p:nvPr>
-        </p:nvSpPr>
-        <p:spPr>
-          <a:xfrm>
-            <a:off x="0" y="8685213"/>
-            <a:ext cx="2971800" cy="457200"/>
-          </a:xfrm>
-          <a:prstGeom prst="rect">
-            <a:avLst/>
-          </a:prstGeom>
-        </p:spPr>
-        <p:txBody>
-          <a:bodyPr vert="horz" lIns="91440" tIns="45720" rIns="91440" bIns="45720" rtlCol="0" anchor="b"/>
-          <a:lstStyle>
-            <a:lvl1pPr algn="l">
-              <a:defRPr sz="1200"/>
-            </a:lvl1pPr>
-          </a:lstStyle>
-          <a:p>
-            <a:endParaRPr lang="en-US"/>
-          </a:p>
-        </p:txBody>
-      </p:sp>
-      <p:sp>
-        <p:nvSpPr>
-          <p:cNvPr id="7" name="Slide Number Placeholder 6"/>
-          <p:cNvSpPr>
-            <a:spLocks noGrp="1"/>
-          </p:cNvSpPr>
-          <p:nvPr>
-            <p:ph type="sldNum" sz="quarter" idx="5"/>
-          </p:nvPr>
-        </p:nvSpPr>
-        <p:spPr>
-          <a:xfrm>
-            <a:off x="3884613" y="8685213"/>
-            <a:ext cx="2971800" cy="457200"/>
-          </a:xfrm>
-          <a:prstGeom prst="rect">
-            <a:avLst/>
-          </a:prstGeom>
-        </p:spPr>
-        <p:txBody>
-          <a:bodyPr vert="horz" lIns="91440" tIns="45720" rIns="91440" bIns="45720" rtlCol="0" anchor="b"/>
-          <a:lstStyle>
-            <a:lvl1pPr algn="r">
-              <a:defRPr sz="1200"/>
-            </a:lvl1pPr>
-          </a:lstStyle>
-          <a:p>
-            <a:fld id="{BB5E49A5-4136-284D-997B-48E1D791AD67}" type="slidenum">
-              <a:rPr lang="en-US" smtClean="0"/>
-              <a:t>‹#›</a:t>
-            </a:fld>
-            <a:endParaRPr lang="en-US"/>
-          </a:p>
-        </p:txBody>
-      </p:sp>
     </p:spTree>
     <p:extLst>
       <p:ext uri="{BB962C8B-B14F-4D97-AF65-F5344CB8AC3E}">
-        <p14:creationId xmlns:p14="http://schemas.microsoft.com/office/powerpoint/2010/main" val="2623252185"/>
+        <p14:creationId xmlns:p14="http://schemas.microsoft.com/office/powerpoint/2010/main" val="205044483"/>
       </p:ext>
     </p:extLst>
   </p:cSld>
   <p:clrMap bg1="lt1" tx1="dk1" bg2="lt2" tx2="dk2" accent1="accent1" accent2="accent2" accent3="accent3" accent4="accent4" accent5="accent5" accent6="accent6" hlink="hlink" folHlink="folHlink"/>
   <p:notesStyle>
-    <a:lvl1pPr marL="0" algn="l" defTabSz="457200" rtl="0" eaLnBrk="1" latinLnBrk="0" hangingPunct="1">
+    <a:lvl1pPr marL="0" algn="l" defTabSz="914400" rtl="0" eaLnBrk="1" latinLnBrk="0" hangingPunct="1">
       <a:defRPr sz="1200" kern="1200">
         <a:solidFill>
           <a:schemeClr val="tx1"/>
@@ -373,7 +167,7 @@
         <a:cs typeface="+mn-cs"/>
       </a:defRPr>
     </a:lvl1pPr>
-    <a:lvl2pPr marL="457200" algn="l" defTabSz="457200" rtl="0" eaLnBrk="1" latinLnBrk="0" hangingPunct="1">
+    <a:lvl2pPr marL="457200" algn="l" defTabSz="914400" rtl="0" eaLnBrk="1" latinLnBrk="0" hangingPunct="1">
       <a:defRPr sz="1200" kern="1200">
         <a:solidFill>
           <a:schemeClr val="tx1"/>
@@ -383,7 +177,7 @@
         <a:cs typeface="+mn-cs"/>
       </a:defRPr>
     </a:lvl2pPr>
-    <a:lvl3pPr marL="914400" algn="l" defTabSz="457200" rtl="0" eaLnBrk="1" latinLnBrk="0" hangingPunct="1">
+    <a:lvl3pPr marL="914400" algn="l" defTabSz="914400" rtl="0" eaLnBrk="1" latinLnBrk="0" hangingPunct="1">
       <a:defRPr sz="1200" kern="1200">
         <a:solidFill>
           <a:schemeClr val="tx1"/>
@@ -393,7 +187,7 @@
         <a:cs typeface="+mn-cs"/>
       </a:defRPr>
     </a:lvl3pPr>
-    <a:lvl4pPr marL="1371600" algn="l" defTabSz="457200" rtl="0" eaLnBrk="1" latinLnBrk="0" hangingPunct="1">
+    <a:lvl4pPr marL="1371600" algn="l" defTabSz="914400" rtl="0" eaLnBrk="1" latinLnBrk="0" hangingPunct="1">
       <a:defRPr sz="1200" kern="1200">
         <a:solidFill>
           <a:schemeClr val="tx1"/>
@@ -403,7 +197,7 @@
         <a:cs typeface="+mn-cs"/>
       </a:defRPr>
     </a:lvl4pPr>
-    <a:lvl5pPr marL="1828800" algn="l" defTabSz="457200" rtl="0" eaLnBrk="1" latinLnBrk="0" hangingPunct="1">
+    <a:lvl5pPr marL="1828800" algn="l" defTabSz="914400" rtl="0" eaLnBrk="1" latinLnBrk="0" hangingPunct="1">
       <a:defRPr sz="1200" kern="1200">
         <a:solidFill>
           <a:schemeClr val="tx1"/>
@@ -413,7 +207,7 @@
         <a:cs typeface="+mn-cs"/>
       </a:defRPr>
     </a:lvl5pPr>
-    <a:lvl6pPr marL="2286000" algn="l" defTabSz="457200" rtl="0" eaLnBrk="1" latinLnBrk="0" hangingPunct="1">
+    <a:lvl6pPr marL="2286000" algn="l" defTabSz="914400" rtl="0" eaLnBrk="1" latinLnBrk="0" hangingPunct="1">
       <a:defRPr sz="1200" kern="1200">
         <a:solidFill>
           <a:schemeClr val="tx1"/>
@@ -423,7 +217,7 @@
         <a:cs typeface="+mn-cs"/>
       </a:defRPr>
     </a:lvl6pPr>
-    <a:lvl7pPr marL="2743200" algn="l" defTabSz="457200" rtl="0" eaLnBrk="1" latinLnBrk="0" hangingPunct="1">
+    <a:lvl7pPr marL="2743200" algn="l" defTabSz="914400" rtl="0" eaLnBrk="1" latinLnBrk="0" hangingPunct="1">
       <a:defRPr sz="1200" kern="1200">
         <a:solidFill>
           <a:schemeClr val="tx1"/>
@@ -433,7 +227,7 @@
         <a:cs typeface="+mn-cs"/>
       </a:defRPr>
     </a:lvl7pPr>
-    <a:lvl8pPr marL="3200400" algn="l" defTabSz="457200" rtl="0" eaLnBrk="1" latinLnBrk="0" hangingPunct="1">
+    <a:lvl8pPr marL="3200400" algn="l" defTabSz="914400" rtl="0" eaLnBrk="1" latinLnBrk="0" hangingPunct="1">
       <a:defRPr sz="1200" kern="1200">
         <a:solidFill>
           <a:schemeClr val="tx1"/>
@@ -443,7 +237,7 @@
         <a:cs typeface="+mn-cs"/>
       </a:defRPr>
     </a:lvl8pPr>
-    <a:lvl9pPr marL="3657600" algn="l" defTabSz="457200" rtl="0" eaLnBrk="1" latinLnBrk="0" hangingPunct="1">
+    <a:lvl9pPr marL="3657600" algn="l" defTabSz="914400" rtl="0" eaLnBrk="1" latinLnBrk="0" hangingPunct="1">
       <a:defRPr sz="1200" kern="1200">
         <a:solidFill>
           <a:schemeClr val="tx1"/>
@@ -458,7 +252,7 @@
 </file>
 
 <file path=ppt/notesSlides/notesSlide1.xml><?xml version="1.0" encoding="utf-8"?>
-<p:notes xmlns:a="http://schemas.openxmlformats.org/drawingml/2006/main" xmlns:p="http://schemas.openxmlformats.org/presentationml/2006/main" xmlns:r="http://schemas.openxmlformats.org/officeDocument/2006/relationships">
+<p:notes xmlns:a="http://schemas.openxmlformats.org/drawingml/2006/main" xmlns:r="http://schemas.openxmlformats.org/officeDocument/2006/relationships" xmlns:p="http://schemas.openxmlformats.org/presentationml/2006/main">
   <p:cSld>
     <p:spTree>
       <p:nvGrpSpPr>
@@ -478,7 +272,7 @@
         <p:nvSpPr>
           <p:cNvPr id="2" name="Slide Image Placeholder 1"/>
           <p:cNvSpPr>
-            <a:spLocks noGrp="1"/>
+            <a:spLocks noGrp="1" noRot="1" noChangeAspect="1"/>
           </p:cNvSpPr>
           <p:nvPr>
             <p:ph type="sldImg" idx="2"/>
@@ -493,7 +287,7 @@
             <a:spLocks noGrp="1"/>
           </p:cNvSpPr>
           <p:nvPr>
-            <p:ph type="body" idx="3" sz="quarter"/>
+            <p:ph type="body" sz="quarter" idx="3"/>
           </p:nvPr>
         </p:nvSpPr>
         <p:spPr/>
@@ -514,7 +308,7 @@
             <a:spLocks noGrp="1"/>
           </p:cNvSpPr>
           <p:nvPr>
-            <p:ph type="sldNum" idx="5" sz="quarter"/>
+            <p:ph type="sldNum" sz="quarter" idx="5"/>
           </p:nvPr>
         </p:nvSpPr>
         <p:spPr/>
@@ -565,10 +359,9 @@
           <a:lstStyle/>
           <a:p>
             <a:r>
-              <a:rPr lang="en-US" smtClean="0"/>
+              <a:rPr lang="en-US"/>
               <a:t>Click to edit Master title style</a:t>
             </a:r>
-            <a:endParaRPr lang="en-US"/>
           </a:p>
         </p:txBody>
       </p:sp>
@@ -684,10 +477,9 @@
           </a:lstStyle>
           <a:p>
             <a:r>
-              <a:rPr lang="en-US" smtClean="0"/>
+              <a:rPr lang="en-US"/>
               <a:t>Click to edit Master subtitle style</a:t>
             </a:r>
-            <a:endParaRPr lang="en-US"/>
           </a:p>
         </p:txBody>
       </p:sp>
@@ -708,7 +500,7 @@
           <a:p>
             <a:fld id="{5BCAD085-E8A6-8845-BD4E-CB4CCA059FC4}" type="datetimeFigureOut">
               <a:rPr lang="en-US" smtClean="0"/>
-              <a:t>1/27/13</a:t>
+              <a:t>6/12/26</a:t>
             </a:fld>
             <a:endParaRPr lang="en-US"/>
           </a:p>
@@ -750,7 +542,7 @@
           <a:p>
             <a:fld id="{C1FF6DA9-008F-8B48-92A6-B652298478BF}" type="slidenum">
               <a:rPr lang="en-US" smtClean="0"/>
-              <a:t>‹#›</a:t>
+              <a:t>‹Nr.›</a:t>
             </a:fld>
             <a:endParaRPr lang="en-US"/>
           </a:p>
@@ -766,6 +558,22 @@
   <p:clrMapOvr>
     <a:masterClrMapping/>
   </p:clrMapOvr>
+  <p:extLst>
+    <p:ext uri="{DCECCB84-F9BA-43D5-87BE-67443E8EF086}">
+      <p15:sldGuideLst xmlns:p15="http://schemas.microsoft.com/office/powerpoint/2012/main">
+        <p15:guide id="1" orient="horz" pos="2160" userDrawn="1">
+          <p15:clr>
+            <a:srgbClr val="FBAE40"/>
+          </p15:clr>
+        </p15:guide>
+        <p15:guide id="2" pos="3840" userDrawn="1">
+          <p15:clr>
+            <a:srgbClr val="FBAE40"/>
+          </p15:clr>
+        </p15:guide>
+      </p15:sldGuideLst>
+    </p:ext>
+  </p:extLst>
 </p:sldLayout>
 </file>
 
@@ -802,10 +610,9 @@
           <a:lstStyle/>
           <a:p>
             <a:r>
-              <a:rPr lang="en-US" smtClean="0"/>
+              <a:rPr lang="en-US"/>
               <a:t>Click to edit Master title style</a:t>
             </a:r>
-            <a:endParaRPr lang="en-US"/>
           </a:p>
         </p:txBody>
       </p:sp>
@@ -826,38 +633,37 @@
           <a:p>
             <a:pPr lvl="0"/>
             <a:r>
-              <a:rPr lang="en-US" smtClean="0"/>
+              <a:rPr lang="en-US"/>
               <a:t>Click to edit Master text styles</a:t>
             </a:r>
           </a:p>
           <a:p>
             <a:pPr lvl="1"/>
             <a:r>
-              <a:rPr lang="en-US" smtClean="0"/>
+              <a:rPr lang="en-US"/>
               <a:t>Second level</a:t>
             </a:r>
           </a:p>
           <a:p>
             <a:pPr lvl="2"/>
             <a:r>
-              <a:rPr lang="en-US" smtClean="0"/>
+              <a:rPr lang="en-US"/>
               <a:t>Third level</a:t>
             </a:r>
           </a:p>
           <a:p>
             <a:pPr lvl="3"/>
             <a:r>
-              <a:rPr lang="en-US" smtClean="0"/>
+              <a:rPr lang="en-US"/>
               <a:t>Fourth level</a:t>
             </a:r>
           </a:p>
           <a:p>
             <a:pPr lvl="4"/>
             <a:r>
-              <a:rPr lang="en-US" smtClean="0"/>
+              <a:rPr lang="en-US"/>
               <a:t>Fifth level</a:t>
             </a:r>
-            <a:endParaRPr lang="en-US"/>
           </a:p>
         </p:txBody>
       </p:sp>
@@ -878,7 +684,7 @@
           <a:p>
             <a:fld id="{5BCAD085-E8A6-8845-BD4E-CB4CCA059FC4}" type="datetimeFigureOut">
               <a:rPr lang="en-US" smtClean="0"/>
-              <a:t>1/27/13</a:t>
+              <a:t>6/12/26</a:t>
             </a:fld>
             <a:endParaRPr lang="en-US"/>
           </a:p>
@@ -920,7 +726,7 @@
           <a:p>
             <a:fld id="{C1FF6DA9-008F-8B48-92A6-B652298478BF}" type="slidenum">
               <a:rPr lang="en-US" smtClean="0"/>
-              <a:t>‹#›</a:t>
+              <a:t>‹Nr.›</a:t>
             </a:fld>
             <a:endParaRPr lang="en-US"/>
           </a:p>
@@ -977,10 +783,9 @@
           <a:lstStyle/>
           <a:p>
             <a:r>
-              <a:rPr lang="en-US" smtClean="0"/>
+              <a:rPr lang="en-US"/>
               <a:t>Click to edit Master title style</a:t>
             </a:r>
-            <a:endParaRPr lang="en-US"/>
           </a:p>
         </p:txBody>
       </p:sp>
@@ -1006,38 +811,37 @@
           <a:p>
             <a:pPr lvl="0"/>
             <a:r>
-              <a:rPr lang="en-US" smtClean="0"/>
+              <a:rPr lang="en-US"/>
               <a:t>Click to edit Master text styles</a:t>
             </a:r>
           </a:p>
           <a:p>
             <a:pPr lvl="1"/>
             <a:r>
-              <a:rPr lang="en-US" smtClean="0"/>
+              <a:rPr lang="en-US"/>
               <a:t>Second level</a:t>
             </a:r>
           </a:p>
           <a:p>
             <a:pPr lvl="2"/>
             <a:r>
-              <a:rPr lang="en-US" smtClean="0"/>
+              <a:rPr lang="en-US"/>
               <a:t>Third level</a:t>
             </a:r>
           </a:p>
           <a:p>
             <a:pPr lvl="3"/>
             <a:r>
-              <a:rPr lang="en-US" smtClean="0"/>
+              <a:rPr lang="en-US"/>
               <a:t>Fourth level</a:t>
             </a:r>
           </a:p>
           <a:p>
             <a:pPr lvl="4"/>
             <a:r>
-              <a:rPr lang="en-US" smtClean="0"/>
+              <a:rPr lang="en-US"/>
               <a:t>Fifth level</a:t>
             </a:r>
-            <a:endParaRPr lang="en-US"/>
           </a:p>
         </p:txBody>
       </p:sp>
@@ -1058,7 +862,7 @@
           <a:p>
             <a:fld id="{5BCAD085-E8A6-8845-BD4E-CB4CCA059FC4}" type="datetimeFigureOut">
               <a:rPr lang="en-US" smtClean="0"/>
-              <a:t>1/27/13</a:t>
+              <a:t>6/12/26</a:t>
             </a:fld>
             <a:endParaRPr lang="en-US"/>
           </a:p>
@@ -1100,7 +904,7 @@
           <a:p>
             <a:fld id="{C1FF6DA9-008F-8B48-92A6-B652298478BF}" type="slidenum">
               <a:rPr lang="en-US" smtClean="0"/>
-              <a:t>‹#›</a:t>
+              <a:t>‹Nr.›</a:t>
             </a:fld>
             <a:endParaRPr lang="en-US"/>
           </a:p>
@@ -1152,10 +956,9 @@
           <a:lstStyle/>
           <a:p>
             <a:r>
-              <a:rPr lang="en-US" smtClean="0"/>
+              <a:rPr lang="en-US"/>
               <a:t>Click to edit Master title style</a:t>
             </a:r>
-            <a:endParaRPr lang="en-US"/>
           </a:p>
         </p:txBody>
       </p:sp>
@@ -1176,38 +979,37 @@
           <a:p>
             <a:pPr lvl="0"/>
             <a:r>
-              <a:rPr lang="en-US" smtClean="0"/>
+              <a:rPr lang="en-US"/>
               <a:t>Click to edit Master text styles</a:t>
             </a:r>
           </a:p>
           <a:p>
             <a:pPr lvl="1"/>
             <a:r>
-              <a:rPr lang="en-US" smtClean="0"/>
+              <a:rPr lang="en-US"/>
               <a:t>Second level</a:t>
             </a:r>
           </a:p>
           <a:p>
             <a:pPr lvl="2"/>
             <a:r>
-              <a:rPr lang="en-US" smtClean="0"/>
+              <a:rPr lang="en-US"/>
               <a:t>Third level</a:t>
             </a:r>
           </a:p>
           <a:p>
             <a:pPr lvl="3"/>
             <a:r>
-              <a:rPr lang="en-US" smtClean="0"/>
+              <a:rPr lang="en-US"/>
               <a:t>Fourth level</a:t>
             </a:r>
           </a:p>
           <a:p>
             <a:pPr lvl="4"/>
             <a:r>
-              <a:rPr lang="en-US" smtClean="0"/>
+              <a:rPr lang="en-US"/>
               <a:t>Fifth level</a:t>
             </a:r>
-            <a:endParaRPr lang="en-US"/>
           </a:p>
         </p:txBody>
       </p:sp>
@@ -1228,7 +1030,7 @@
           <a:p>
             <a:fld id="{5BCAD085-E8A6-8845-BD4E-CB4CCA059FC4}" type="datetimeFigureOut">
               <a:rPr lang="en-US" smtClean="0"/>
-              <a:t>1/27/13</a:t>
+              <a:t>6/12/26</a:t>
             </a:fld>
             <a:endParaRPr lang="en-US"/>
           </a:p>
@@ -1270,7 +1072,7 @@
           <a:p>
             <a:fld id="{C1FF6DA9-008F-8B48-92A6-B652298478BF}" type="slidenum">
               <a:rPr lang="en-US" smtClean="0"/>
-              <a:t>‹#›</a:t>
+              <a:t>‹Nr.›</a:t>
             </a:fld>
             <a:endParaRPr lang="en-US"/>
           </a:p>
@@ -1331,10 +1133,9 @@
           </a:lstStyle>
           <a:p>
             <a:r>
-              <a:rPr lang="en-US" smtClean="0"/>
+              <a:rPr lang="en-US"/>
               <a:t>Click to edit Master title style</a:t>
             </a:r>
-            <a:endParaRPr lang="en-US"/>
           </a:p>
         </p:txBody>
       </p:sp>
@@ -1451,7 +1252,7 @@
           <a:p>
             <a:pPr lvl="0"/>
             <a:r>
-              <a:rPr lang="en-US" smtClean="0"/>
+              <a:rPr lang="en-US"/>
               <a:t>Click to edit Master text styles</a:t>
             </a:r>
           </a:p>
@@ -1474,7 +1275,7 @@
           <a:p>
             <a:fld id="{5BCAD085-E8A6-8845-BD4E-CB4CCA059FC4}" type="datetimeFigureOut">
               <a:rPr lang="en-US" smtClean="0"/>
-              <a:t>1/27/13</a:t>
+              <a:t>6/12/26</a:t>
             </a:fld>
             <a:endParaRPr lang="en-US"/>
           </a:p>
@@ -1516,7 +1317,7 @@
           <a:p>
             <a:fld id="{C1FF6DA9-008F-8B48-92A6-B652298478BF}" type="slidenum">
               <a:rPr lang="en-US" smtClean="0"/>
-              <a:t>‹#›</a:t>
+              <a:t>‹Nr.›</a:t>
             </a:fld>
             <a:endParaRPr lang="en-US"/>
           </a:p>
@@ -1568,10 +1369,9 @@
           <a:lstStyle/>
           <a:p>
             <a:r>
-              <a:rPr lang="en-US" smtClean="0"/>
+              <a:rPr lang="en-US"/>
               <a:t>Click to edit Master title style</a:t>
             </a:r>
-            <a:endParaRPr lang="en-US"/>
           </a:p>
         </p:txBody>
       </p:sp>
@@ -1625,38 +1425,37 @@
           <a:p>
             <a:pPr lvl="0"/>
             <a:r>
-              <a:rPr lang="en-US" smtClean="0"/>
+              <a:rPr lang="en-US"/>
               <a:t>Click to edit Master text styles</a:t>
             </a:r>
           </a:p>
           <a:p>
             <a:pPr lvl="1"/>
             <a:r>
-              <a:rPr lang="en-US" smtClean="0"/>
+              <a:rPr lang="en-US"/>
               <a:t>Second level</a:t>
             </a:r>
           </a:p>
           <a:p>
             <a:pPr lvl="2"/>
             <a:r>
-              <a:rPr lang="en-US" smtClean="0"/>
+              <a:rPr lang="en-US"/>
               <a:t>Third level</a:t>
             </a:r>
           </a:p>
           <a:p>
             <a:pPr lvl="3"/>
             <a:r>
-              <a:rPr lang="en-US" smtClean="0"/>
+              <a:rPr lang="en-US"/>
               <a:t>Fourth level</a:t>
             </a:r>
           </a:p>
           <a:p>
             <a:pPr lvl="4"/>
             <a:r>
-              <a:rPr lang="en-US" smtClean="0"/>
+              <a:rPr lang="en-US"/>
               <a:t>Fifth level</a:t>
             </a:r>
-            <a:endParaRPr lang="en-US"/>
           </a:p>
         </p:txBody>
       </p:sp>
@@ -1710,38 +1509,37 @@
           <a:p>
             <a:pPr lvl="0"/>
             <a:r>
-              <a:rPr lang="en-US" smtClean="0"/>
+              <a:rPr lang="en-US"/>
               <a:t>Click to edit Master text styles</a:t>
             </a:r>
           </a:p>
           <a:p>
             <a:pPr lvl="1"/>
             <a:r>
-              <a:rPr lang="en-US" smtClean="0"/>
+              <a:rPr lang="en-US"/>
               <a:t>Second level</a:t>
             </a:r>
           </a:p>
           <a:p>
             <a:pPr lvl="2"/>
             <a:r>
-              <a:rPr lang="en-US" smtClean="0"/>
+              <a:rPr lang="en-US"/>
               <a:t>Third level</a:t>
             </a:r>
           </a:p>
           <a:p>
             <a:pPr lvl="3"/>
             <a:r>
-              <a:rPr lang="en-US" smtClean="0"/>
+              <a:rPr lang="en-US"/>
               <a:t>Fourth level</a:t>
             </a:r>
           </a:p>
           <a:p>
             <a:pPr lvl="4"/>
             <a:r>
-              <a:rPr lang="en-US" smtClean="0"/>
+              <a:rPr lang="en-US"/>
               <a:t>Fifth level</a:t>
             </a:r>
-            <a:endParaRPr lang="en-US"/>
           </a:p>
         </p:txBody>
       </p:sp>
@@ -1762,7 +1560,7 @@
           <a:p>
             <a:fld id="{5BCAD085-E8A6-8845-BD4E-CB4CCA059FC4}" type="datetimeFigureOut">
               <a:rPr lang="en-US" smtClean="0"/>
-              <a:t>1/27/13</a:t>
+              <a:t>6/12/26</a:t>
             </a:fld>
             <a:endParaRPr lang="en-US"/>
           </a:p>
@@ -1804,7 +1602,7 @@
           <a:p>
             <a:fld id="{C1FF6DA9-008F-8B48-92A6-B652298478BF}" type="slidenum">
               <a:rPr lang="en-US" smtClean="0"/>
-              <a:t>‹#›</a:t>
+              <a:t>‹Nr.›</a:t>
             </a:fld>
             <a:endParaRPr lang="en-US"/>
           </a:p>
@@ -1860,10 +1658,9 @@
           </a:lstStyle>
           <a:p>
             <a:r>
-              <a:rPr lang="en-US" smtClean="0"/>
+              <a:rPr lang="en-US"/>
               <a:t>Click to edit Master title style</a:t>
             </a:r>
-            <a:endParaRPr lang="en-US"/>
           </a:p>
         </p:txBody>
       </p:sp>
@@ -1926,7 +1723,7 @@
           <a:p>
             <a:pPr lvl="0"/>
             <a:r>
-              <a:rPr lang="en-US" smtClean="0"/>
+              <a:rPr lang="en-US"/>
               <a:t>Click to edit Master text styles</a:t>
             </a:r>
           </a:p>
@@ -1982,38 +1779,37 @@
           <a:p>
             <a:pPr lvl="0"/>
             <a:r>
-              <a:rPr lang="en-US" smtClean="0"/>
+              <a:rPr lang="en-US"/>
               <a:t>Click to edit Master text styles</a:t>
             </a:r>
           </a:p>
           <a:p>
             <a:pPr lvl="1"/>
             <a:r>
-              <a:rPr lang="en-US" smtClean="0"/>
+              <a:rPr lang="en-US"/>
               <a:t>Second level</a:t>
             </a:r>
           </a:p>
           <a:p>
             <a:pPr lvl="2"/>
             <a:r>
-              <a:rPr lang="en-US" smtClean="0"/>
+              <a:rPr lang="en-US"/>
               <a:t>Third level</a:t>
             </a:r>
           </a:p>
           <a:p>
             <a:pPr lvl="3"/>
             <a:r>
-              <a:rPr lang="en-US" smtClean="0"/>
+              <a:rPr lang="en-US"/>
               <a:t>Fourth level</a:t>
             </a:r>
           </a:p>
           <a:p>
             <a:pPr lvl="4"/>
             <a:r>
-              <a:rPr lang="en-US" smtClean="0"/>
+              <a:rPr lang="en-US"/>
               <a:t>Fifth level</a:t>
             </a:r>
-            <a:endParaRPr lang="en-US"/>
           </a:p>
         </p:txBody>
       </p:sp>
@@ -2076,7 +1872,7 @@
           <a:p>
             <a:pPr lvl="0"/>
             <a:r>
-              <a:rPr lang="en-US" smtClean="0"/>
+              <a:rPr lang="en-US"/>
               <a:t>Click to edit Master text styles</a:t>
             </a:r>
           </a:p>
@@ -2132,38 +1928,37 @@
           <a:p>
             <a:pPr lvl="0"/>
             <a:r>
-              <a:rPr lang="en-US" smtClean="0"/>
+              <a:rPr lang="en-US"/>
               <a:t>Click to edit Master text styles</a:t>
             </a:r>
           </a:p>
           <a:p>
             <a:pPr lvl="1"/>
             <a:r>
-              <a:rPr lang="en-US" smtClean="0"/>
+              <a:rPr lang="en-US"/>
               <a:t>Second level</a:t>
             </a:r>
           </a:p>
           <a:p>
             <a:pPr lvl="2"/>
             <a:r>
-              <a:rPr lang="en-US" smtClean="0"/>
+              <a:rPr lang="en-US"/>
               <a:t>Third level</a:t>
             </a:r>
           </a:p>
           <a:p>
             <a:pPr lvl="3"/>
             <a:r>
-              <a:rPr lang="en-US" smtClean="0"/>
+              <a:rPr lang="en-US"/>
               <a:t>Fourth level</a:t>
             </a:r>
           </a:p>
           <a:p>
             <a:pPr lvl="4"/>
             <a:r>
-              <a:rPr lang="en-US" smtClean="0"/>
+              <a:rPr lang="en-US"/>
               <a:t>Fifth level</a:t>
             </a:r>
-            <a:endParaRPr lang="en-US"/>
           </a:p>
         </p:txBody>
       </p:sp>
@@ -2184,7 +1979,7 @@
           <a:p>
             <a:fld id="{5BCAD085-E8A6-8845-BD4E-CB4CCA059FC4}" type="datetimeFigureOut">
               <a:rPr lang="en-US" smtClean="0"/>
-              <a:t>1/27/13</a:t>
+              <a:t>6/12/26</a:t>
             </a:fld>
             <a:endParaRPr lang="en-US"/>
           </a:p>
@@ -2226,7 +2021,7 @@
           <a:p>
             <a:fld id="{C1FF6DA9-008F-8B48-92A6-B652298478BF}" type="slidenum">
               <a:rPr lang="en-US" smtClean="0"/>
-              <a:t>‹#›</a:t>
+              <a:t>‹Nr.›</a:t>
             </a:fld>
             <a:endParaRPr lang="en-US"/>
           </a:p>
@@ -2278,10 +2073,9 @@
           <a:lstStyle/>
           <a:p>
             <a:r>
-              <a:rPr lang="en-US" smtClean="0"/>
+              <a:rPr lang="en-US"/>
               <a:t>Click to edit Master title style</a:t>
             </a:r>
-            <a:endParaRPr lang="en-US"/>
           </a:p>
         </p:txBody>
       </p:sp>
@@ -2302,7 +2096,7 @@
           <a:p>
             <a:fld id="{5BCAD085-E8A6-8845-BD4E-CB4CCA059FC4}" type="datetimeFigureOut">
               <a:rPr lang="en-US" smtClean="0"/>
-              <a:t>1/27/13</a:t>
+              <a:t>6/12/26</a:t>
             </a:fld>
             <a:endParaRPr lang="en-US"/>
           </a:p>
@@ -2344,7 +2138,7 @@
           <a:p>
             <a:fld id="{C1FF6DA9-008F-8B48-92A6-B652298478BF}" type="slidenum">
               <a:rPr lang="en-US" smtClean="0"/>
-              <a:t>‹#›</a:t>
+              <a:t>‹Nr.›</a:t>
             </a:fld>
             <a:endParaRPr lang="en-US"/>
           </a:p>
@@ -2397,7 +2191,7 @@
           <a:p>
             <a:fld id="{5BCAD085-E8A6-8845-BD4E-CB4CCA059FC4}" type="datetimeFigureOut">
               <a:rPr lang="en-US" smtClean="0"/>
-              <a:t>1/27/13</a:t>
+              <a:t>6/12/26</a:t>
             </a:fld>
             <a:endParaRPr lang="en-US"/>
           </a:p>
@@ -2439,7 +2233,7 @@
           <a:p>
             <a:fld id="{C1FF6DA9-008F-8B48-92A6-B652298478BF}" type="slidenum">
               <a:rPr lang="en-US" smtClean="0"/>
-              <a:t>‹#›</a:t>
+              <a:t>‹Nr.›</a:t>
             </a:fld>
             <a:endParaRPr lang="en-US"/>
           </a:p>
@@ -2500,10 +2294,9 @@
           </a:lstStyle>
           <a:p>
             <a:r>
-              <a:rPr lang="en-US" smtClean="0"/>
+              <a:rPr lang="en-US"/>
               <a:t>Click to edit Master title style</a:t>
             </a:r>
-            <a:endParaRPr lang="en-US"/>
           </a:p>
         </p:txBody>
       </p:sp>
@@ -2557,38 +2350,37 @@
           <a:p>
             <a:pPr lvl="0"/>
             <a:r>
-              <a:rPr lang="en-US" smtClean="0"/>
+              <a:rPr lang="en-US"/>
               <a:t>Click to edit Master text styles</a:t>
             </a:r>
           </a:p>
           <a:p>
             <a:pPr lvl="1"/>
             <a:r>
-              <a:rPr lang="en-US" smtClean="0"/>
+              <a:rPr lang="en-US"/>
               <a:t>Second level</a:t>
             </a:r>
           </a:p>
           <a:p>
             <a:pPr lvl="2"/>
             <a:r>
-              <a:rPr lang="en-US" smtClean="0"/>
+              <a:rPr lang="en-US"/>
               <a:t>Third level</a:t>
             </a:r>
           </a:p>
           <a:p>
             <a:pPr lvl="3"/>
             <a:r>
-              <a:rPr lang="en-US" smtClean="0"/>
+              <a:rPr lang="en-US"/>
               <a:t>Fourth level</a:t>
             </a:r>
           </a:p>
           <a:p>
             <a:pPr lvl="4"/>
             <a:r>
-              <a:rPr lang="en-US" smtClean="0"/>
+              <a:rPr lang="en-US"/>
               <a:t>Fifth level</a:t>
             </a:r>
-            <a:endParaRPr lang="en-US"/>
           </a:p>
         </p:txBody>
       </p:sp>
@@ -2651,7 +2443,7 @@
           <a:p>
             <a:pPr lvl="0"/>
             <a:r>
-              <a:rPr lang="en-US" smtClean="0"/>
+              <a:rPr lang="en-US"/>
               <a:t>Click to edit Master text styles</a:t>
             </a:r>
           </a:p>
@@ -2674,7 +2466,7 @@
           <a:p>
             <a:fld id="{5BCAD085-E8A6-8845-BD4E-CB4CCA059FC4}" type="datetimeFigureOut">
               <a:rPr lang="en-US" smtClean="0"/>
-              <a:t>1/27/13</a:t>
+              <a:t>6/12/26</a:t>
             </a:fld>
             <a:endParaRPr lang="en-US"/>
           </a:p>
@@ -2716,7 +2508,7 @@
           <a:p>
             <a:fld id="{C1FF6DA9-008F-8B48-92A6-B652298478BF}" type="slidenum">
               <a:rPr lang="en-US" smtClean="0"/>
-              <a:t>‹#›</a:t>
+              <a:t>‹Nr.›</a:t>
             </a:fld>
             <a:endParaRPr lang="en-US"/>
           </a:p>
@@ -2777,10 +2569,9 @@
           </a:lstStyle>
           <a:p>
             <a:r>
-              <a:rPr lang="en-US" smtClean="0"/>
+              <a:rPr lang="en-US"/>
               <a:t>Click to edit Master title style</a:t>
             </a:r>
-            <a:endParaRPr lang="en-US"/>
           </a:p>
         </p:txBody>
       </p:sp>
@@ -2904,7 +2695,7 @@
           <a:p>
             <a:pPr lvl="0"/>
             <a:r>
-              <a:rPr lang="en-US" smtClean="0"/>
+              <a:rPr lang="en-US"/>
               <a:t>Click to edit Master text styles</a:t>
             </a:r>
           </a:p>
@@ -2927,7 +2718,7 @@
           <a:p>
             <a:fld id="{5BCAD085-E8A6-8845-BD4E-CB4CCA059FC4}" type="datetimeFigureOut">
               <a:rPr lang="en-US" smtClean="0"/>
-              <a:t>1/27/13</a:t>
+              <a:t>6/12/26</a:t>
             </a:fld>
             <a:endParaRPr lang="en-US"/>
           </a:p>
@@ -2969,7 +2760,7 @@
           <a:p>
             <a:fld id="{C1FF6DA9-008F-8B48-92A6-B652298478BF}" type="slidenum">
               <a:rPr lang="en-US" smtClean="0"/>
-              <a:t>‹#›</a:t>
+              <a:t>‹Nr.›</a:t>
             </a:fld>
             <a:endParaRPr lang="en-US"/>
           </a:p>
@@ -3036,10 +2827,9 @@
           <a:lstStyle/>
           <a:p>
             <a:r>
-              <a:rPr lang="en-US" smtClean="0"/>
+              <a:rPr lang="en-US"/>
               <a:t>Click to edit Master title style</a:t>
             </a:r>
-            <a:endParaRPr lang="en-US"/>
           </a:p>
         </p:txBody>
       </p:sp>
@@ -3070,38 +2860,37 @@
           <a:p>
             <a:pPr lvl="0"/>
             <a:r>
-              <a:rPr lang="en-US" smtClean="0"/>
+              <a:rPr lang="en-US"/>
               <a:t>Click to edit Master text styles</a:t>
             </a:r>
           </a:p>
           <a:p>
             <a:pPr lvl="1"/>
             <a:r>
-              <a:rPr lang="en-US" smtClean="0"/>
+              <a:rPr lang="en-US"/>
               <a:t>Second level</a:t>
             </a:r>
           </a:p>
           <a:p>
             <a:pPr lvl="2"/>
             <a:r>
-              <a:rPr lang="en-US" smtClean="0"/>
+              <a:rPr lang="en-US"/>
               <a:t>Third level</a:t>
             </a:r>
           </a:p>
           <a:p>
             <a:pPr lvl="3"/>
             <a:r>
-              <a:rPr lang="en-US" smtClean="0"/>
+              <a:rPr lang="en-US"/>
               <a:t>Fourth level</a:t>
             </a:r>
           </a:p>
           <a:p>
             <a:pPr lvl="4"/>
             <a:r>
-              <a:rPr lang="en-US" smtClean="0"/>
+              <a:rPr lang="en-US"/>
               <a:t>Fifth level</a:t>
             </a:r>
-            <a:endParaRPr lang="en-US"/>
           </a:p>
         </p:txBody>
       </p:sp>
@@ -3140,7 +2929,7 @@
           <a:p>
             <a:fld id="{5BCAD085-E8A6-8845-BD4E-CB4CCA059FC4}" type="datetimeFigureOut">
               <a:rPr lang="en-US" smtClean="0"/>
-              <a:t>1/27/13</a:t>
+              <a:t>6/12/26</a:t>
             </a:fld>
             <a:endParaRPr lang="en-US"/>
           </a:p>
@@ -3218,7 +3007,7 @@
           <a:p>
             <a:fld id="{C1FF6DA9-008F-8B48-92A6-B652298478BF}" type="slidenum">
               <a:rPr lang="en-US" smtClean="0"/>
-              <a:t>‹#›</a:t>
+              <a:t>‹Nr.›</a:t>
             </a:fld>
             <a:endParaRPr lang="en-US"/>
           </a:p>
@@ -3499,7 +3288,7 @@
 </file>
 
 <file path=ppt/slides/slide1.xml><?xml version="1.0" encoding="utf-8"?>
-<p:sld xmlns:a="http://schemas.openxmlformats.org/drawingml/2006/main" xmlns:p="http://schemas.openxmlformats.org/presentationml/2006/main" xmlns:r="http://schemas.openxmlformats.org/officeDocument/2006/relationships">
+<p:sld xmlns:a="http://schemas.openxmlformats.org/drawingml/2006/main" xmlns:r="http://schemas.openxmlformats.org/officeDocument/2006/relationships" xmlns:p="http://schemas.openxmlformats.org/presentationml/2006/main">
   <p:cSld>
     <p:spTree>
       <p:nvGrpSpPr>
@@ -3507,7 +3296,14 @@
         <p:cNvGrpSpPr/>
         <p:nvPr/>
       </p:nvGrpSpPr>
-      <p:grpSpPr/>
+      <p:grpSpPr>
+        <a:xfrm>
+          <a:off x="0" y="0"/>
+          <a:ext cx="0" cy="0"/>
+          <a:chOff x="0" y="0"/>
+          <a:chExt cx="0" cy="0"/>
+        </a:xfrm>
+      </p:grpSpPr>
       <p:sp>
         <p:nvSpPr>
           <p:cNvPr id="2" name="Title 1"/>
@@ -3524,14 +3320,30 @@
           <a:lstStyle/>
           <a:p>
             <a:r>
-              <a:t>Seed</a:t>
-            </a:r>
-          </a:p>
-        </p:txBody>
-      </p:sp>
-      <p:sp>
-        <p:nvSpPr>
-          <p:cNvPr id="3" name="Subtitle 2"/>
+              <a:rPr lang="de-DE" dirty="0" err="1"/>
+              <a:t>pptc</a:t>
+            </a:r>
+            <a:r>
+              <a:rPr lang="de-DE" dirty="0"/>
+              <a:t> </a:t>
+            </a:r>
+            <a:r>
+              <a:rPr lang="de-DE" dirty="0" err="1"/>
+              <a:t>default</a:t>
+            </a:r>
+            <a:endParaRPr dirty="0"/>
+          </a:p>
+        </p:txBody>
+      </p:sp>
+      <p:sp>
+        <p:nvSpPr>
+          <p:cNvPr id="4" name="Untertitel 3">
+            <a:extLst>
+              <a:ext uri="{FF2B5EF4-FFF2-40B4-BE49-F238E27FC236}">
+                <a16:creationId xmlns:a16="http://schemas.microsoft.com/office/drawing/2014/main" id="{8F460410-FB2E-9888-E14E-A55B7D50BA14}"/>
+              </a:ext>
+            </a:extLst>
+          </p:cNvPr>
           <p:cNvSpPr>
             <a:spLocks noGrp="1"/>
           </p:cNvSpPr>
@@ -3543,7 +3355,9 @@
         <p:txBody>
           <a:bodyPr/>
           <a:lstStyle/>
-          <a:p/>
+          <a:p>
+            <a:endParaRPr lang="en-US"/>
+          </a:p>
         </p:txBody>
       </p:sp>
     </p:spTree>
@@ -3875,7 +3689,7 @@
 </file>
 
 <file path=ppt/theme/theme2.xml><?xml version="1.0" encoding="utf-8"?>
-<a:theme xmlns:a="http://schemas.openxmlformats.org/drawingml/2006/main" name="Office Theme">
+<a:theme xmlns:a="http://schemas.openxmlformats.org/drawingml/2006/main" name="Office">
   <a:themeElements>
     <a:clrScheme name="Office">
       <a:dk1>
@@ -3885,44 +3699,44 @@
         <a:sysClr val="window" lastClr="FFFFFF"/>
       </a:lt1>
       <a:dk2>
-        <a:srgbClr val="1F497D"/>
+        <a:srgbClr val="0E2841"/>
       </a:dk2>
       <a:lt2>
-        <a:srgbClr val="EEECE1"/>
+        <a:srgbClr val="E8E8E8"/>
       </a:lt2>
       <a:accent1>
-        <a:srgbClr val="4F81BD"/>
+        <a:srgbClr val="156082"/>
       </a:accent1>
       <a:accent2>
-        <a:srgbClr val="C0504D"/>
+        <a:srgbClr val="E97132"/>
       </a:accent2>
       <a:accent3>
-        <a:srgbClr val="9BBB59"/>
+        <a:srgbClr val="196B24"/>
       </a:accent3>
       <a:accent4>
-        <a:srgbClr val="8064A2"/>
+        <a:srgbClr val="0F9ED5"/>
       </a:accent4>
       <a:accent5>
-        <a:srgbClr val="4BACC6"/>
+        <a:srgbClr val="A02B93"/>
       </a:accent5>
       <a:accent6>
-        <a:srgbClr val="F79646"/>
+        <a:srgbClr val="4EA72E"/>
       </a:accent6>
       <a:hlink>
-        <a:srgbClr val="0000FF"/>
+        <a:srgbClr val="467886"/>
       </a:hlink>
       <a:folHlink>
-        <a:srgbClr val="800080"/>
+        <a:srgbClr val="96607D"/>
       </a:folHlink>
     </a:clrScheme>
     <a:fontScheme name="Office">
       <a:majorFont>
-        <a:latin typeface="Calibri"/>
+        <a:latin typeface="Aptos Display" panose="02110004020202020204"/>
         <a:ea typeface=""/>
         <a:cs typeface=""/>
-        <a:font script="Jpan" typeface="ＭＳ Ｐゴシック"/>
+        <a:font script="Jpan" typeface="游ゴシック Light"/>
         <a:font script="Hang" typeface="맑은 고딕"/>
-        <a:font script="Hans" typeface="宋体"/>
+        <a:font script="Hans" typeface="等线 Light"/>
         <a:font script="Hant" typeface="新細明體"/>
         <a:font script="Arab" typeface="Times New Roman"/>
         <a:font script="Hebr" typeface="Times New Roman"/>
@@ -3950,14 +3764,31 @@
         <a:font script="Viet" typeface="Times New Roman"/>
         <a:font script="Uigh" typeface="Microsoft Uighur"/>
         <a:font script="Geor" typeface="Sylfaen"/>
+        <a:font script="Armn" typeface="Arial"/>
+        <a:font script="Bugi" typeface="Leelawadee UI"/>
+        <a:font script="Bopo" typeface="Microsoft JhengHei"/>
+        <a:font script="Java" typeface="Javanese Text"/>
+        <a:font script="Lisu" typeface="Segoe UI"/>
+        <a:font script="Mymr" typeface="Myanmar Text"/>
+        <a:font script="Nkoo" typeface="Ebrima"/>
+        <a:font script="Olck" typeface="Nirmala UI"/>
+        <a:font script="Osma" typeface="Ebrima"/>
+        <a:font script="Phag" typeface="Phagspa"/>
+        <a:font script="Syrn" typeface="Estrangelo Edessa"/>
+        <a:font script="Syrj" typeface="Estrangelo Edessa"/>
+        <a:font script="Syre" typeface="Estrangelo Edessa"/>
+        <a:font script="Sora" typeface="Nirmala UI"/>
+        <a:font script="Tale" typeface="Microsoft Tai Le"/>
+        <a:font script="Talu" typeface="Microsoft New Tai Lue"/>
+        <a:font script="Tfng" typeface="Ebrima"/>
       </a:majorFont>
       <a:minorFont>
-        <a:latin typeface="Calibri"/>
+        <a:latin typeface="Aptos" panose="02110004020202020204"/>
         <a:ea typeface=""/>
         <a:cs typeface=""/>
-        <a:font script="Jpan" typeface="ＭＳ Ｐゴシック"/>
+        <a:font script="Jpan" typeface="游ゴシック"/>
         <a:font script="Hang" typeface="맑은 고딕"/>
-        <a:font script="Hans" typeface="宋体"/>
+        <a:font script="Hans" typeface="等线"/>
         <a:font script="Hant" typeface="新細明體"/>
         <a:font script="Arab" typeface="Arial"/>
         <a:font script="Hebr" typeface="Arial"/>
@@ -3985,6 +3816,23 @@
         <a:font script="Viet" typeface="Arial"/>
         <a:font script="Uigh" typeface="Microsoft Uighur"/>
         <a:font script="Geor" typeface="Sylfaen"/>
+        <a:font script="Armn" typeface="Arial"/>
+        <a:font script="Bugi" typeface="Leelawadee UI"/>
+        <a:font script="Bopo" typeface="Microsoft JhengHei"/>
+        <a:font script="Java" typeface="Javanese Text"/>
+        <a:font script="Lisu" typeface="Segoe UI"/>
+        <a:font script="Mymr" typeface="Myanmar Text"/>
+        <a:font script="Nkoo" typeface="Ebrima"/>
+        <a:font script="Olck" typeface="Nirmala UI"/>
+        <a:font script="Osma" typeface="Ebrima"/>
+        <a:font script="Phag" typeface="Phagspa"/>
+        <a:font script="Syrn" typeface="Estrangelo Edessa"/>
+        <a:font script="Syrj" typeface="Estrangelo Edessa"/>
+        <a:font script="Syre" typeface="Estrangelo Edessa"/>
+        <a:font script="Sora" typeface="Nirmala UI"/>
+        <a:font script="Tale" typeface="Microsoft Tai Le"/>
+        <a:font script="Talu" typeface="Microsoft New Tai Lue"/>
+        <a:font script="Tfng" typeface="Ebrima"/>
       </a:minorFont>
     </a:fontScheme>
     <a:fmtScheme name="Office">
@@ -3996,180 +3844,136 @@
           <a:gsLst>
             <a:gs pos="0">
               <a:schemeClr val="phClr">
-                <a:tint val="50000"/>
-                <a:satMod val="300000"/>
+                <a:lumMod val="110000"/>
+                <a:satMod val="105000"/>
+                <a:tint val="67000"/>
               </a:schemeClr>
             </a:gs>
-            <a:gs pos="35000">
+            <a:gs pos="50000">
               <a:schemeClr val="phClr">
-                <a:tint val="37000"/>
-                <a:satMod val="300000"/>
+                <a:lumMod val="105000"/>
+                <a:satMod val="103000"/>
+                <a:tint val="73000"/>
               </a:schemeClr>
             </a:gs>
             <a:gs pos="100000">
               <a:schemeClr val="phClr">
-                <a:tint val="15000"/>
-                <a:satMod val="350000"/>
+                <a:lumMod val="105000"/>
+                <a:satMod val="109000"/>
+                <a:tint val="81000"/>
               </a:schemeClr>
             </a:gs>
           </a:gsLst>
-          <a:lin ang="16200000" scaled="1"/>
+          <a:lin ang="5400000" scaled="0"/>
         </a:gradFill>
         <a:gradFill rotWithShape="1">
           <a:gsLst>
             <a:gs pos="0">
               <a:schemeClr val="phClr">
-                <a:tint val="100000"/>
+                <a:satMod val="103000"/>
+                <a:lumMod val="102000"/>
+                <a:tint val="94000"/>
+              </a:schemeClr>
+            </a:gs>
+            <a:gs pos="50000">
+              <a:schemeClr val="phClr">
+                <a:satMod val="110000"/>
+                <a:lumMod val="100000"/>
                 <a:shade val="100000"/>
-                <a:satMod val="130000"/>
               </a:schemeClr>
             </a:gs>
             <a:gs pos="100000">
               <a:schemeClr val="phClr">
-                <a:tint val="50000"/>
-                <a:shade val="100000"/>
-                <a:satMod val="350000"/>
+                <a:lumMod val="99000"/>
+                <a:satMod val="120000"/>
+                <a:shade val="78000"/>
               </a:schemeClr>
             </a:gs>
           </a:gsLst>
-          <a:lin ang="16200000" scaled="0"/>
+          <a:lin ang="5400000" scaled="0"/>
         </a:gradFill>
       </a:fillStyleLst>
       <a:lnStyleLst>
-        <a:ln w="9525" cap="flat" cmpd="sng" algn="ctr">
+        <a:ln w="12700" cap="flat" cmpd="sng" algn="ctr">
           <a:solidFill>
-            <a:schemeClr val="phClr">
-              <a:shade val="95000"/>
-              <a:satMod val="105000"/>
-            </a:schemeClr>
+            <a:schemeClr val="phClr"/>
           </a:solidFill>
           <a:prstDash val="solid"/>
+          <a:miter lim="800000"/>
+        </a:ln>
+        <a:ln w="19050" cap="flat" cmpd="sng" algn="ctr">
+          <a:solidFill>
+            <a:schemeClr val="phClr"/>
+          </a:solidFill>
+          <a:prstDash val="solid"/>
+          <a:miter lim="800000"/>
         </a:ln>
         <a:ln w="25400" cap="flat" cmpd="sng" algn="ctr">
           <a:solidFill>
             <a:schemeClr val="phClr"/>
           </a:solidFill>
           <a:prstDash val="solid"/>
-        </a:ln>
-        <a:ln w="38100" cap="flat" cmpd="sng" algn="ctr">
-          <a:solidFill>
-            <a:schemeClr val="phClr"/>
-          </a:solidFill>
-          <a:prstDash val="solid"/>
+          <a:miter lim="800000"/>
         </a:ln>
       </a:lnStyleLst>
       <a:effectStyleLst>
         <a:effectStyle>
+          <a:effectLst/>
+        </a:effectStyle>
+        <a:effectStyle>
+          <a:effectLst/>
+        </a:effectStyle>
+        <a:effectStyle>
           <a:effectLst>
-            <a:outerShdw blurRad="40000" dist="20000" dir="5400000" rotWithShape="0">
+            <a:outerShdw blurRad="57150" dist="19050" dir="5400000" algn="ctr" rotWithShape="0">
               <a:srgbClr val="000000">
-                <a:alpha val="38000"/>
+                <a:alpha val="63000"/>
               </a:srgbClr>
             </a:outerShdw>
           </a:effectLst>
-        </a:effectStyle>
-        <a:effectStyle>
-          <a:effectLst>
-            <a:outerShdw blurRad="40000" dist="23000" dir="5400000" rotWithShape="0">
-              <a:srgbClr val="000000">
-                <a:alpha val="35000"/>
-              </a:srgbClr>
-            </a:outerShdw>
-          </a:effectLst>
-        </a:effectStyle>
-        <a:effectStyle>
-          <a:effectLst>
-            <a:outerShdw blurRad="40000" dist="23000" dir="5400000" rotWithShape="0">
-              <a:srgbClr val="000000">
-                <a:alpha val="35000"/>
-              </a:srgbClr>
-            </a:outerShdw>
-          </a:effectLst>
-          <a:scene3d>
-            <a:camera prst="orthographicFront">
-              <a:rot lat="0" lon="0" rev="0"/>
-            </a:camera>
-            <a:lightRig rig="threePt" dir="t">
-              <a:rot lat="0" lon="0" rev="1200000"/>
-            </a:lightRig>
-          </a:scene3d>
-          <a:sp3d>
-            <a:bevelT w="63500" h="25400"/>
-          </a:sp3d>
         </a:effectStyle>
       </a:effectStyleLst>
       <a:bgFillStyleLst>
         <a:solidFill>
           <a:schemeClr val="phClr"/>
         </a:solidFill>
+        <a:solidFill>
+          <a:schemeClr val="phClr">
+            <a:tint val="95000"/>
+            <a:satMod val="170000"/>
+          </a:schemeClr>
+        </a:solidFill>
         <a:gradFill rotWithShape="1">
           <a:gsLst>
             <a:gs pos="0">
               <a:schemeClr val="phClr">
-                <a:tint val="40000"/>
-                <a:satMod val="350000"/>
+                <a:tint val="93000"/>
+                <a:satMod val="150000"/>
+                <a:shade val="98000"/>
+                <a:lumMod val="102000"/>
               </a:schemeClr>
             </a:gs>
-            <a:gs pos="40000">
+            <a:gs pos="50000">
               <a:schemeClr val="phClr">
-                <a:tint val="45000"/>
-                <a:shade val="99000"/>
-                <a:satMod val="350000"/>
+                <a:tint val="98000"/>
+                <a:satMod val="130000"/>
+                <a:shade val="90000"/>
+                <a:lumMod val="103000"/>
               </a:schemeClr>
             </a:gs>
             <a:gs pos="100000">
               <a:schemeClr val="phClr">
-                <a:shade val="20000"/>
-                <a:satMod val="255000"/>
+                <a:shade val="63000"/>
+                <a:satMod val="120000"/>
               </a:schemeClr>
             </a:gs>
           </a:gsLst>
-          <a:path path="circle">
-            <a:fillToRect l="50000" t="-80000" r="50000" b="180000"/>
-          </a:path>
-        </a:gradFill>
-        <a:gradFill rotWithShape="1">
-          <a:gsLst>
-            <a:gs pos="0">
-              <a:schemeClr val="phClr">
-                <a:tint val="80000"/>
-                <a:satMod val="300000"/>
-              </a:schemeClr>
-            </a:gs>
-            <a:gs pos="100000">
-              <a:schemeClr val="phClr">
-                <a:shade val="30000"/>
-                <a:satMod val="200000"/>
-              </a:schemeClr>
-            </a:gs>
-          </a:gsLst>
-          <a:path path="circle">
-            <a:fillToRect l="50000" t="50000" r="50000" b="50000"/>
-          </a:path>
+          <a:lin ang="5400000" scaled="0"/>
         </a:gradFill>
       </a:bgFillStyleLst>
     </a:fmtScheme>
   </a:themeElements>
   <a:objectDefaults>
-    <a:spDef>
-      <a:spPr/>
-      <a:bodyPr/>
-      <a:lstStyle/>
-      <a:style>
-        <a:lnRef idx="1">
-          <a:schemeClr val="accent1"/>
-        </a:lnRef>
-        <a:fillRef idx="3">
-          <a:schemeClr val="accent1"/>
-        </a:fillRef>
-        <a:effectRef idx="2">
-          <a:schemeClr val="accent1"/>
-        </a:effectRef>
-        <a:fontRef idx="minor">
-          <a:schemeClr val="lt1"/>
-        </a:fontRef>
-      </a:style>
-    </a:spDef>
     <a:lnDef>
       <a:spPr/>
       <a:bodyPr/>
@@ -4191,5 +3995,10 @@
     </a:lnDef>
   </a:objectDefaults>
   <a:extraClrSchemeLst/>
+  <a:extLst>
+    <a:ext uri="{05A4C25C-085E-4340-85A3-A5531E510DB2}">
+      <thm15:themeFamily xmlns:thm15="http://schemas.microsoft.com/office/thememl/2012/main" name="Office Theme" id="{2E142A2C-CD16-42D6-873A-C26D2A0506FA}" vid="{1BDDFF52-6CD6-40A5-AB3C-68EB2F1E4D0A}"/>
+    </a:ext>
+  </a:extLst>
 </a:theme>
 </file>
</xml_diff>